<commit_message>
chore: save final UAT presentation updates
</commit_message>
<xml_diff>
--- a/.codex-finalizer/loanstar-uat-progress-candidate.pptx
+++ b/.codex-finalizer/loanstar-uat-progress-candidate.pptx
@@ -2,29 +2,29 @@
 <file path=ppt/presentation.xml><?xml version="1.0" encoding="utf-8"?>
 <p:presentation xmlns:p="http://schemas.openxmlformats.org/presentationml/2006/main">
   <p:sldMasterIdLst>
-    <p:sldMasterId xmlns:r="http://schemas.openxmlformats.org/officeDocument/2006/relationships" id="2147483648" r:id="R4c41a6b4108f46bc"/>
+    <p:sldMasterId xmlns:r="http://schemas.openxmlformats.org/officeDocument/2006/relationships" id="2147483648" r:id="Rd567ebed468a4ee8"/>
   </p:sldMasterIdLst>
   <p:notesMasterIdLst>
-    <p:notesMasterId xmlns:r="http://schemas.openxmlformats.org/officeDocument/2006/relationships" r:id="R3d91d596a1d1488c"/>
+    <p:notesMasterId xmlns:r="http://schemas.openxmlformats.org/officeDocument/2006/relationships" r:id="R0f99cb6328884c85"/>
   </p:notesMasterIdLst>
   <p:sldIdLst>
-    <p:sldId xmlns:r="http://schemas.openxmlformats.org/officeDocument/2006/relationships" id="256" r:id="R857165094ece48ca"/>
-    <p:sldId xmlns:r="http://schemas.openxmlformats.org/officeDocument/2006/relationships" id="257" r:id="Rf75ecf4f309a4bc8"/>
-    <p:sldId xmlns:r="http://schemas.openxmlformats.org/officeDocument/2006/relationships" id="258" r:id="Rb93b83725b0a4d84"/>
-    <p:sldId xmlns:r="http://schemas.openxmlformats.org/officeDocument/2006/relationships" id="259" r:id="R21f8e0932a9b4ab5"/>
-    <p:sldId xmlns:r="http://schemas.openxmlformats.org/officeDocument/2006/relationships" id="260" r:id="R80308544169048d8"/>
-    <p:sldId xmlns:r="http://schemas.openxmlformats.org/officeDocument/2006/relationships" id="261" r:id="Rcfa51210bbaf403d"/>
-    <p:sldId xmlns:r="http://schemas.openxmlformats.org/officeDocument/2006/relationships" id="262" r:id="R758ce54af95d45c3"/>
-    <p:sldId xmlns:r="http://schemas.openxmlformats.org/officeDocument/2006/relationships" id="263" r:id="R7609146eb62e43a5"/>
-    <p:sldId xmlns:r="http://schemas.openxmlformats.org/officeDocument/2006/relationships" id="264" r:id="R191afc7f584747c3"/>
-    <p:sldId xmlns:r="http://schemas.openxmlformats.org/officeDocument/2006/relationships" id="265" r:id="R29a32a885d914b6c"/>
-    <p:sldId xmlns:r="http://schemas.openxmlformats.org/officeDocument/2006/relationships" id="266" r:id="R882211f1feca4784"/>
-    <p:sldId xmlns:r="http://schemas.openxmlformats.org/officeDocument/2006/relationships" id="267" r:id="R36e2040595424310"/>
-    <p:sldId xmlns:r="http://schemas.openxmlformats.org/officeDocument/2006/relationships" id="268" r:id="R928657a642fc4c2f"/>
-    <p:sldId xmlns:r="http://schemas.openxmlformats.org/officeDocument/2006/relationships" id="269" r:id="R6a2762c3316d4162"/>
-    <p:sldId xmlns:r="http://schemas.openxmlformats.org/officeDocument/2006/relationships" id="270" r:id="R9f41e458a3044be6"/>
-    <p:sldId xmlns:r="http://schemas.openxmlformats.org/officeDocument/2006/relationships" id="271" r:id="R10408fb6bf2d484f"/>
-    <p:sldId xmlns:r="http://schemas.openxmlformats.org/officeDocument/2006/relationships" id="272" r:id="R17ea5a6610f64cad"/>
+    <p:sldId xmlns:r="http://schemas.openxmlformats.org/officeDocument/2006/relationships" id="256" r:id="R1d44b2c36a8949db"/>
+    <p:sldId xmlns:r="http://schemas.openxmlformats.org/officeDocument/2006/relationships" id="257" r:id="R9a5f50fedb284031"/>
+    <p:sldId xmlns:r="http://schemas.openxmlformats.org/officeDocument/2006/relationships" id="258" r:id="R7ad72a6cf72940c9"/>
+    <p:sldId xmlns:r="http://schemas.openxmlformats.org/officeDocument/2006/relationships" id="259" r:id="R3b98bd7e835e41a2"/>
+    <p:sldId xmlns:r="http://schemas.openxmlformats.org/officeDocument/2006/relationships" id="260" r:id="R15f5867ca46f4b97"/>
+    <p:sldId xmlns:r="http://schemas.openxmlformats.org/officeDocument/2006/relationships" id="261" r:id="Re0e14fbbc20146a6"/>
+    <p:sldId xmlns:r="http://schemas.openxmlformats.org/officeDocument/2006/relationships" id="262" r:id="Reba29a16d18d4739"/>
+    <p:sldId xmlns:r="http://schemas.openxmlformats.org/officeDocument/2006/relationships" id="263" r:id="R378544aec7c241ab"/>
+    <p:sldId xmlns:r="http://schemas.openxmlformats.org/officeDocument/2006/relationships" id="264" r:id="R10799373919d4d4a"/>
+    <p:sldId xmlns:r="http://schemas.openxmlformats.org/officeDocument/2006/relationships" id="265" r:id="R591aa9f659134431"/>
+    <p:sldId xmlns:r="http://schemas.openxmlformats.org/officeDocument/2006/relationships" id="266" r:id="R50f379625cc5477e"/>
+    <p:sldId xmlns:r="http://schemas.openxmlformats.org/officeDocument/2006/relationships" id="267" r:id="Rb2b097445a394e43"/>
+    <p:sldId xmlns:r="http://schemas.openxmlformats.org/officeDocument/2006/relationships" id="268" r:id="R5531178dd70c496c"/>
+    <p:sldId xmlns:r="http://schemas.openxmlformats.org/officeDocument/2006/relationships" id="269" r:id="Rc16cd00c17744880"/>
+    <p:sldId xmlns:r="http://schemas.openxmlformats.org/officeDocument/2006/relationships" id="270" r:id="R6fa7bec5640b4437"/>
+    <p:sldId xmlns:r="http://schemas.openxmlformats.org/officeDocument/2006/relationships" id="271" r:id="Ra538dec9e5af4bc4"/>
+    <p:sldId xmlns:r="http://schemas.openxmlformats.org/officeDocument/2006/relationships" id="272" r:id="Ra8bf5a3a35a64c9e"/>
   </p:sldIdLst>
   <p:sldSz cx="12192000" cy="6858000"/>
   <p:notesSz cx="6858000" cy="9144000"/>
@@ -1952,7 +1952,7 @@
   </p:cSld>
   <p:clrMap bg1="lt1" tx1="dk1" bg2="lt2" tx2="dk2" accent1="accent1" accent2="accent2" accent3="accent3" accent4="accent4" accent5="accent5" accent6="accent6" hlink="hlink" folHlink="folHlink"/>
   <p:sldLayoutIdLst>
-    <p:sldLayoutId xmlns:r="http://schemas.openxmlformats.org/officeDocument/2006/relationships" id="2147483649" r:id="R7a36de76c1f14efa"/>
+    <p:sldLayoutId xmlns:r="http://schemas.openxmlformats.org/officeDocument/2006/relationships" id="2147483649" r:id="R1c31bb67e03149c9"/>
   </p:sldLayoutIdLst>
   <p:txStyles>
     <p:titleStyle>
@@ -9534,7 +9534,7 @@
                           <a:ea typeface="Aptos"/>
                           <a:cs typeface="Aptos"/>
                         </a:rPr>
-                        <a:t>Disabled access immediately; reactivation requires fresh access</a:t>
+                        <a:t>Disabled access immediately; reactivation restores access</a:t>
                       </a:r>
                     </a:p>
                   </a:txBody>

</xml_diff>